<commit_message>
Simplify 4-phase timeline to clean single-row layout
Remove cluttered central-axis design; use four equal aligned boxes,
subtle arrows, minimal labels, and clear visual hierarchy.

Co-authored-by: sazmanfava854-sudo <sazmanfava854-sudo@users.noreply.github.com>
</commit_message>
<xml_diff>
--- a/presentations/چهار_فاز_اصلی_سامانه_تایم‌لاین.pptx
+++ b/presentations/چهار_فاز_اصلی_سامانه_تایم‌لاین.pptx
@@ -3103,7 +3103,7 @@
             <a:avLst/>
           </a:prstGeom>
           <a:solidFill>
-            <a:srgbClr val="F7F9FC"/>
+            <a:srgbClr val="FAFBFC"/>
           </a:solidFill>
           <a:ln>
             <a:noFill/>
@@ -3133,20 +3133,90 @@
       </p:sp>
       <p:sp>
         <p:nvSpPr>
-          <p:cNvPr id="3" name="Rectangle 2"/>
-          <p:cNvSpPr/>
+          <p:cNvPr id="3" name="TextBox 2"/>
+          <p:cNvSpPr txBox="1"/>
           <p:nvPr/>
         </p:nvSpPr>
         <p:spPr>
           <a:xfrm>
-            <a:off x="0" y="0"/>
-            <a:ext cx="9144000" cy="91440"/>
+            <a:off x="548640" y="411480"/>
+            <a:ext cx="8046720" cy="411480"/>
           </a:xfrm>
           <a:prstGeom prst="rect">
             <a:avLst/>
           </a:prstGeom>
+          <a:noFill/>
+        </p:spPr>
+        <p:txBody>
+          <a:bodyPr wrap="square" anchor="ctr">
+            <a:spAutoFit/>
+          </a:bodyPr>
+          <a:lstStyle/>
+          <a:p>
+            <a:pPr algn="r" a:rtl="1"/>
+            <a:r>
+              <a:rPr sz="2400" b="1">
+                <a:solidFill>
+                  <a:srgbClr val="1E293B"/>
+                </a:solidFill>
+                <a:latin typeface="Tahoma"/>
+              </a:rPr>
+              <a:t>چهار فاز اصلی سامانه</a:t>
+            </a:r>
+          </a:p>
+        </p:txBody>
+      </p:sp>
+      <p:sp>
+        <p:nvSpPr>
+          <p:cNvPr id="4" name="TextBox 3"/>
+          <p:cNvSpPr txBox="1"/>
+          <p:nvPr/>
+        </p:nvSpPr>
+        <p:spPr>
+          <a:xfrm>
+            <a:off x="548640" y="868680"/>
+            <a:ext cx="8046720" cy="274320"/>
+          </a:xfrm>
+          <a:prstGeom prst="rect">
+            <a:avLst/>
+          </a:prstGeom>
+          <a:noFill/>
+        </p:spPr>
+        <p:txBody>
+          <a:bodyPr wrap="square" anchor="ctr">
+            <a:spAutoFit/>
+          </a:bodyPr>
+          <a:lstStyle/>
+          <a:p>
+            <a:pPr algn="r" a:rtl="1"/>
+            <a:r>
+              <a:rPr sz="1100" b="0">
+                <a:solidFill>
+                  <a:srgbClr val="64748B"/>
+                </a:solidFill>
+                <a:latin typeface="Tahoma"/>
+              </a:rPr>
+              <a:t>خوشه‌بندی  →  AHP  →  تعدیل پویا  →  TOPSIS</a:t>
+            </a:r>
+          </a:p>
+        </p:txBody>
+      </p:sp>
+      <p:sp>
+        <p:nvSpPr>
+          <p:cNvPr id="5" name="Right Arrow 4"/>
+          <p:cNvSpPr/>
+          <p:nvPr/>
+        </p:nvSpPr>
+        <p:spPr>
+          <a:xfrm rot="10800000">
+            <a:off x="6336793" y="2564892"/>
+            <a:ext cx="384048" cy="128016"/>
+          </a:xfrm>
+          <a:prstGeom prst="rightArrow">
+            <a:avLst/>
+          </a:prstGeom>
           <a:solidFill>
-            <a:srgbClr val="1E3A5F"/>
+            <a:srgbClr val="CBD5E1"/>
           </a:solidFill>
           <a:ln>
             <a:noFill/>
@@ -3176,90 +3246,20 @@
       </p:sp>
       <p:sp>
         <p:nvSpPr>
-          <p:cNvPr id="4" name="TextBox 3"/>
-          <p:cNvSpPr txBox="1"/>
-          <p:nvPr/>
-        </p:nvSpPr>
-        <p:spPr>
-          <a:xfrm>
-            <a:off x="411480" y="256032"/>
-            <a:ext cx="8321040" cy="457200"/>
-          </a:xfrm>
-          <a:prstGeom prst="rect">
-            <a:avLst/>
-          </a:prstGeom>
-          <a:noFill/>
-        </p:spPr>
-        <p:txBody>
-          <a:bodyPr wrap="square" anchor="ctr">
-            <a:spAutoFit/>
-          </a:bodyPr>
-          <a:lstStyle/>
-          <a:p>
-            <a:pPr algn="r" a:rtl="1"/>
-            <a:r>
-              <a:rPr sz="2600" b="1">
-                <a:solidFill>
-                  <a:srgbClr val="1E3A5F"/>
-                </a:solidFill>
-                <a:latin typeface="Tahoma"/>
-              </a:rPr>
-              <a:t>چهار فاز اصلی سامانه</a:t>
-            </a:r>
-          </a:p>
-        </p:txBody>
-      </p:sp>
-      <p:sp>
-        <p:nvSpPr>
-          <p:cNvPr id="5" name="TextBox 4"/>
-          <p:cNvSpPr txBox="1"/>
-          <p:nvPr/>
-        </p:nvSpPr>
-        <p:spPr>
-          <a:xfrm>
-            <a:off x="411480" y="713232"/>
-            <a:ext cx="8321040" cy="292608"/>
-          </a:xfrm>
-          <a:prstGeom prst="rect">
-            <a:avLst/>
-          </a:prstGeom>
-          <a:noFill/>
-        </p:spPr>
-        <p:txBody>
-          <a:bodyPr wrap="square" anchor="ctr">
-            <a:spAutoFit/>
-          </a:bodyPr>
-          <a:lstStyle/>
-          <a:p>
-            <a:pPr algn="r" a:rtl="1"/>
-            <a:r>
-              <a:rPr sz="1200" b="0">
-                <a:solidFill>
-                  <a:srgbClr val="6B7280"/>
-                </a:solidFill>
-                <a:latin typeface="Tahoma"/>
-              </a:rPr>
-              <a:t>از خوشه‌بندی تا رتبه‌بندی نهایی فناوری‌ها</a:t>
-            </a:r>
-          </a:p>
-        </p:txBody>
-      </p:sp>
-      <p:sp>
-        <p:nvSpPr>
-          <p:cNvPr id="6" name="Rectangle 5"/>
+          <p:cNvPr id="6" name="Right Arrow 5"/>
           <p:cNvSpPr/>
           <p:nvPr/>
         </p:nvSpPr>
         <p:spPr>
-          <a:xfrm>
-            <a:off x="822960" y="2743200"/>
-            <a:ext cx="7498080" cy="91440"/>
-          </a:xfrm>
-          <a:prstGeom prst="rect">
+          <a:xfrm rot="10800000">
+            <a:off x="4078226" y="2564892"/>
+            <a:ext cx="384048" cy="128016"/>
+          </a:xfrm>
+          <a:prstGeom prst="rightArrow">
             <a:avLst/>
           </a:prstGeom>
           <a:solidFill>
-            <a:srgbClr val="1E3A5F"/>
+            <a:srgbClr val="CBD5E1"/>
           </a:solidFill>
           <a:ln>
             <a:noFill/>
@@ -3289,20 +3289,20 @@
       </p:sp>
       <p:sp>
         <p:nvSpPr>
-          <p:cNvPr id="7" name="Rectangle 6"/>
+          <p:cNvPr id="7" name="Right Arrow 6"/>
           <p:cNvSpPr/>
           <p:nvPr/>
         </p:nvSpPr>
         <p:spPr>
-          <a:xfrm>
-            <a:off x="822960" y="2724912"/>
-            <a:ext cx="7498080" cy="22860"/>
-          </a:xfrm>
-          <a:prstGeom prst="rect">
+          <a:xfrm rot="10800000">
+            <a:off x="1819659" y="2564892"/>
+            <a:ext cx="384048" cy="128016"/>
+          </a:xfrm>
+          <a:prstGeom prst="rightArrow">
             <a:avLst/>
           </a:prstGeom>
           <a:solidFill>
-            <a:srgbClr val="FFFFFF"/>
+            <a:srgbClr val="CBD5E1"/>
           </a:solidFill>
           <a:ln>
             <a:noFill/>
@@ -3332,20 +3332,22 @@
       </p:sp>
       <p:sp>
         <p:nvSpPr>
-          <p:cNvPr id="8" name="Rectangle 7"/>
+          <p:cNvPr id="8" name="Rounded Rectangle 7"/>
           <p:cNvSpPr/>
           <p:nvPr/>
         </p:nvSpPr>
         <p:spPr>
           <a:xfrm>
-            <a:off x="2197608" y="2743200"/>
-            <a:ext cx="4748784" cy="91440"/>
-          </a:xfrm>
-          <a:prstGeom prst="rect">
-            <a:avLst/>
+            <a:off x="6720841" y="1920240"/>
+            <a:ext cx="1874519" cy="1417320"/>
+          </a:xfrm>
+          <a:prstGeom prst="roundRect">
+            <a:avLst>
+              <a:gd name="adj" fmla="val 8000"/>
+            </a:avLst>
           </a:prstGeom>
           <a:solidFill>
-            <a:srgbClr val="009688"/>
+            <a:srgbClr val="2563EB"/>
           </a:solidFill>
           <a:ln>
             <a:noFill/>
@@ -3381,8 +3383,8 @@
         </p:nvSpPr>
         <p:spPr>
           <a:xfrm>
-            <a:off x="8001000" y="2468880"/>
-            <a:ext cx="640080" cy="640080"/>
+            <a:off x="7420356" y="1975104"/>
+            <a:ext cx="475488" cy="475488"/>
           </a:xfrm>
           <a:prstGeom prst="ellipse">
             <a:avLst/>
@@ -3390,10 +3392,8 @@
           <a:solidFill>
             <a:srgbClr val="FFFFFF"/>
           </a:solidFill>
-          <a:ln w="38100">
-            <a:solidFill>
-              <a:srgbClr val="2B5C8A"/>
-            </a:solidFill>
+          <a:ln>
+            <a:noFill/>
           </a:ln>
         </p:spPr>
         <p:style>
@@ -3415,25 +3415,106 @@
           <a:lstStyle/>
           <a:p>
             <a:pPr algn="ctr"/>
-          </a:p>
-        </p:txBody>
-      </p:sp>
-      <p:sp>
-        <p:nvSpPr>
-          <p:cNvPr id="10" name="Oval 9"/>
+            <a:r>
+              <a:rPr sz="1200" b="1">
+                <a:solidFill>
+                  <a:srgbClr val="2563EB"/>
+                </a:solidFill>
+                <a:latin typeface="Tahoma"/>
+              </a:rPr>
+              <a:t>۱</a:t>
+            </a:r>
+          </a:p>
+        </p:txBody>
+      </p:sp>
+      <p:sp>
+        <p:nvSpPr>
+          <p:cNvPr id="10" name="TextBox 9"/>
+          <p:cNvSpPr txBox="1"/>
+          <p:nvPr/>
+        </p:nvSpPr>
+        <p:spPr>
+          <a:xfrm>
+            <a:off x="6812281" y="2395728"/>
+            <a:ext cx="1691639" cy="274320"/>
+          </a:xfrm>
+          <a:prstGeom prst="rect">
+            <a:avLst/>
+          </a:prstGeom>
+          <a:noFill/>
+        </p:spPr>
+        <p:txBody>
+          <a:bodyPr wrap="square" anchor="ctr">
+            <a:spAutoFit/>
+          </a:bodyPr>
+          <a:lstStyle/>
+          <a:p>
+            <a:pPr algn="ctr" a:rtl="1"/>
+            <a:r>
+              <a:rPr sz="1200" b="1">
+                <a:solidFill>
+                  <a:srgbClr val="FFFFFF"/>
+                </a:solidFill>
+                <a:latin typeface="Tahoma"/>
+              </a:rPr>
+              <a:t>خوشه‌بندی</a:t>
+            </a:r>
+          </a:p>
+        </p:txBody>
+      </p:sp>
+      <p:sp>
+        <p:nvSpPr>
+          <p:cNvPr id="11" name="TextBox 10"/>
+          <p:cNvSpPr txBox="1"/>
+          <p:nvPr/>
+        </p:nvSpPr>
+        <p:spPr>
+          <a:xfrm>
+            <a:off x="6812281" y="2670048"/>
+            <a:ext cx="1691639" cy="502920"/>
+          </a:xfrm>
+          <a:prstGeom prst="rect">
+            <a:avLst/>
+          </a:prstGeom>
+          <a:noFill/>
+        </p:spPr>
+        <p:txBody>
+          <a:bodyPr wrap="square" anchor="ctr">
+            <a:spAutoFit/>
+          </a:bodyPr>
+          <a:lstStyle/>
+          <a:p>
+            <a:pPr algn="ctr" a:rtl="1"/>
+            <a:r>
+              <a:rPr sz="850" b="0">
+                <a:solidFill>
+                  <a:srgbClr val="DBEAFE"/>
+                </a:solidFill>
+                <a:latin typeface="Tahoma"/>
+              </a:rPr>
+              <a:t>گروه‌بندی فناوری‌ها بر اساس ویژگی‌های فنی و اقتصادی</a:t>
+            </a:r>
+          </a:p>
+        </p:txBody>
+      </p:sp>
+      <p:sp>
+        <p:nvSpPr>
+          <p:cNvPr id="12" name="Rounded Rectangle 11"/>
           <p:cNvSpPr/>
           <p:nvPr/>
         </p:nvSpPr>
         <p:spPr>
           <a:xfrm>
-            <a:off x="8046720" y="2514600"/>
-            <a:ext cx="548640" cy="548640"/>
-          </a:xfrm>
-          <a:prstGeom prst="ellipse">
-            <a:avLst/>
+            <a:off x="4462274" y="1920240"/>
+            <a:ext cx="1874519" cy="1417320"/>
+          </a:xfrm>
+          <a:prstGeom prst="roundRect">
+            <a:avLst>
+              <a:gd name="adj" fmla="val 8000"/>
+            </a:avLst>
           </a:prstGeom>
           <a:solidFill>
-            <a:srgbClr val="2B5C8A"/>
+            <a:srgbClr val="2563EB"/>
           </a:solidFill>
           <a:ln>
             <a:noFill/>
@@ -3458,41 +3539,28 @@
           <a:lstStyle/>
           <a:p>
             <a:pPr algn="ctr"/>
-            <a:r>
-              <a:rPr sz="1500" b="1">
-                <a:solidFill>
-                  <a:srgbClr val="FFFFFF"/>
-                </a:solidFill>
-                <a:latin typeface="Tahoma"/>
-              </a:rPr>
-              <a:t>۱</a:t>
-            </a:r>
-          </a:p>
-        </p:txBody>
-      </p:sp>
-      <p:sp>
-        <p:nvSpPr>
-          <p:cNvPr id="11" name="Rounded Rectangle 10"/>
+          </a:p>
+        </p:txBody>
+      </p:sp>
+      <p:sp>
+        <p:nvSpPr>
+          <p:cNvPr id="13" name="Oval 12"/>
           <p:cNvSpPr/>
           <p:nvPr/>
         </p:nvSpPr>
         <p:spPr>
           <a:xfrm>
-            <a:off x="7383780" y="1463040"/>
-            <a:ext cx="1874519" cy="868680"/>
-          </a:xfrm>
-          <a:prstGeom prst="roundRect">
-            <a:avLst>
-              <a:gd name="adj" fmla="val 10000"/>
-            </a:avLst>
+            <a:off x="5161789" y="1975104"/>
+            <a:ext cx="475488" cy="475488"/>
+          </a:xfrm>
+          <a:prstGeom prst="ellipse">
+            <a:avLst/>
           </a:prstGeom>
           <a:solidFill>
             <a:srgbClr val="FFFFFF"/>
           </a:solidFill>
-          <a:ln w="15240">
-            <a:solidFill>
-              <a:srgbClr val="D1D9E6"/>
-            </a:solidFill>
+          <a:ln>
+            <a:noFill/>
           </a:ln>
         </p:spPr>
         <p:style>
@@ -3514,19 +3582,28 @@
           <a:lstStyle/>
           <a:p>
             <a:pPr algn="ctr"/>
-          </a:p>
-        </p:txBody>
-      </p:sp>
-      <p:sp>
-        <p:nvSpPr>
-          <p:cNvPr id="12" name="TextBox 11"/>
+            <a:r>
+              <a:rPr sz="1200" b="1">
+                <a:solidFill>
+                  <a:srgbClr val="2563EB"/>
+                </a:solidFill>
+                <a:latin typeface="Tahoma"/>
+              </a:rPr>
+              <a:t>۲</a:t>
+            </a:r>
+          </a:p>
+        </p:txBody>
+      </p:sp>
+      <p:sp>
+        <p:nvSpPr>
+          <p:cNvPr id="14" name="TextBox 13"/>
           <p:cNvSpPr txBox="1"/>
           <p:nvPr/>
         </p:nvSpPr>
         <p:spPr>
           <a:xfrm>
-            <a:off x="7475220" y="1572768"/>
-            <a:ext cx="1691639" cy="292608"/>
+            <a:off x="4553714" y="2395728"/>
+            <a:ext cx="1691639" cy="274320"/>
           </a:xfrm>
           <a:prstGeom prst="rect">
             <a:avLst/>
@@ -3541,27 +3618,27 @@
           <a:p>
             <a:pPr algn="ctr" a:rtl="1"/>
             <a:r>
-              <a:rPr sz="1100" b="1">
+              <a:rPr sz="1200" b="1">
                 <a:solidFill>
-                  <a:srgbClr val="2D343E"/>
+                  <a:srgbClr val="FFFFFF"/>
                 </a:solidFill>
                 <a:latin typeface="Tahoma"/>
               </a:rPr>
-              <a:t>خوشه‌بندی فناوری‌ها</a:t>
-            </a:r>
-          </a:p>
-        </p:txBody>
-      </p:sp>
-      <p:sp>
-        <p:nvSpPr>
-          <p:cNvPr id="13" name="TextBox 12"/>
+              <a:t>وزن پایه AHP</a:t>
+            </a:r>
+          </a:p>
+        </p:txBody>
+      </p:sp>
+      <p:sp>
+        <p:nvSpPr>
+          <p:cNvPr id="15" name="TextBox 14"/>
           <p:cNvSpPr txBox="1"/>
           <p:nvPr/>
         </p:nvSpPr>
         <p:spPr>
           <a:xfrm>
-            <a:off x="7475220" y="1865376"/>
-            <a:ext cx="1691639" cy="457200"/>
+            <a:off x="4553714" y="2670048"/>
+            <a:ext cx="1691639" cy="502920"/>
           </a:xfrm>
           <a:prstGeom prst="rect">
             <a:avLst/>
@@ -3576,36 +3653,40 @@
           <a:p>
             <a:pPr algn="ctr" a:rtl="1"/>
             <a:r>
-              <a:rPr sz="900" b="0">
+              <a:rPr sz="850" b="0">
                 <a:solidFill>
-                  <a:srgbClr val="6B7280"/>
+                  <a:srgbClr val="DBEAFE"/>
                 </a:solidFill>
                 <a:latin typeface="Tahoma"/>
               </a:rPr>
-              <a:t>گروه‌بندی بر اساس ویژگی‌های فنی و اقتصادی</a:t>
-            </a:r>
-          </a:p>
-        </p:txBody>
-      </p:sp>
-      <p:sp>
-        <p:nvSpPr>
-          <p:cNvPr id="14" name="Rectangle 13"/>
+              <a:t>محاسبه اهمیت نسبی معیارها از قضاوت خبرگان</a:t>
+            </a:r>
+          </a:p>
+        </p:txBody>
+      </p:sp>
+      <p:sp>
+        <p:nvSpPr>
+          <p:cNvPr id="16" name="Rounded Rectangle 15"/>
           <p:cNvSpPr/>
           <p:nvPr/>
         </p:nvSpPr>
         <p:spPr>
           <a:xfrm>
-            <a:off x="8305800" y="2331720"/>
-            <a:ext cx="30480" cy="146304"/>
-          </a:xfrm>
-          <a:prstGeom prst="rect">
-            <a:avLst/>
+            <a:off x="2167131" y="1883664"/>
+            <a:ext cx="1947671" cy="1490472"/>
+          </a:xfrm>
+          <a:prstGeom prst="roundRect">
+            <a:avLst>
+              <a:gd name="adj" fmla="val 8000"/>
+            </a:avLst>
           </a:prstGeom>
           <a:solidFill>
-            <a:srgbClr val="2B5C8A"/>
+            <a:srgbClr val="F0FAF9"/>
           </a:solidFill>
-          <a:ln>
-            <a:noFill/>
+          <a:ln w="19050">
+            <a:solidFill>
+              <a:srgbClr val="009688"/>
+            </a:solidFill>
           </a:ln>
         </p:spPr>
         <p:style>
@@ -3632,60 +3713,25 @@
       </p:sp>
       <p:sp>
         <p:nvSpPr>
-          <p:cNvPr id="15" name="TextBox 14"/>
-          <p:cNvSpPr txBox="1"/>
-          <p:nvPr/>
-        </p:nvSpPr>
-        <p:spPr>
-          <a:xfrm>
-            <a:off x="7909560" y="3172968"/>
-            <a:ext cx="822960" cy="201168"/>
-          </a:xfrm>
-          <a:prstGeom prst="rect">
-            <a:avLst/>
-          </a:prstGeom>
-          <a:noFill/>
-        </p:spPr>
-        <p:txBody>
-          <a:bodyPr wrap="square" anchor="ctr">
-            <a:spAutoFit/>
-          </a:bodyPr>
-          <a:lstStyle/>
-          <a:p>
-            <a:pPr algn="ctr" a:rtl="1"/>
-            <a:r>
-              <a:rPr sz="800" b="1">
-                <a:solidFill>
-                  <a:srgbClr val="2B5C8A"/>
-                </a:solidFill>
-                <a:latin typeface="Tahoma"/>
-              </a:rPr>
-              <a:t>شروع</a:t>
-            </a:r>
-          </a:p>
-        </p:txBody>
-      </p:sp>
-      <p:sp>
-        <p:nvSpPr>
-          <p:cNvPr id="16" name="Oval 15"/>
+          <p:cNvPr id="17" name="Rounded Rectangle 16"/>
           <p:cNvSpPr/>
           <p:nvPr/>
         </p:nvSpPr>
         <p:spPr>
           <a:xfrm>
-            <a:off x="5501640" y="2468880"/>
-            <a:ext cx="640080" cy="640080"/>
-          </a:xfrm>
-          <a:prstGeom prst="ellipse">
-            <a:avLst/>
+            <a:off x="2203707" y="1920240"/>
+            <a:ext cx="1874519" cy="1417320"/>
+          </a:xfrm>
+          <a:prstGeom prst="roundRect">
+            <a:avLst>
+              <a:gd name="adj" fmla="val 8000"/>
+            </a:avLst>
           </a:prstGeom>
           <a:solidFill>
-            <a:srgbClr val="FFFFFF"/>
+            <a:srgbClr val="009688"/>
           </a:solidFill>
-          <a:ln w="38100">
-            <a:solidFill>
-              <a:srgbClr val="2B5C8A"/>
-            </a:solidFill>
+          <a:ln>
+            <a:noFill/>
           </a:ln>
         </p:spPr>
         <p:style>
@@ -3712,20 +3758,20 @@
       </p:sp>
       <p:sp>
         <p:nvSpPr>
-          <p:cNvPr id="17" name="Oval 16"/>
+          <p:cNvPr id="18" name="Oval 17"/>
           <p:cNvSpPr/>
           <p:nvPr/>
         </p:nvSpPr>
         <p:spPr>
           <a:xfrm>
-            <a:off x="5547360" y="2514600"/>
-            <a:ext cx="548640" cy="548640"/>
+            <a:off x="2903222" y="1975104"/>
+            <a:ext cx="475488" cy="475488"/>
           </a:xfrm>
           <a:prstGeom prst="ellipse">
             <a:avLst/>
           </a:prstGeom>
           <a:solidFill>
-            <a:srgbClr val="2B5C8A"/>
+            <a:srgbClr val="FFFFFF"/>
           </a:solidFill>
           <a:ln>
             <a:noFill/>
@@ -3751,40 +3797,108 @@
           <a:p>
             <a:pPr algn="ctr"/>
             <a:r>
-              <a:rPr sz="1500" b="1">
+              <a:rPr sz="1200" b="1">
+                <a:solidFill>
+                  <a:srgbClr val="009688"/>
+                </a:solidFill>
+                <a:latin typeface="Tahoma"/>
+              </a:rPr>
+              <a:t>۳</a:t>
+            </a:r>
+          </a:p>
+        </p:txBody>
+      </p:sp>
+      <p:sp>
+        <p:nvSpPr>
+          <p:cNvPr id="19" name="TextBox 18"/>
+          <p:cNvSpPr txBox="1"/>
+          <p:nvPr/>
+        </p:nvSpPr>
+        <p:spPr>
+          <a:xfrm>
+            <a:off x="2295147" y="2395728"/>
+            <a:ext cx="1691639" cy="274320"/>
+          </a:xfrm>
+          <a:prstGeom prst="rect">
+            <a:avLst/>
+          </a:prstGeom>
+          <a:noFill/>
+        </p:spPr>
+        <p:txBody>
+          <a:bodyPr wrap="square" anchor="ctr">
+            <a:spAutoFit/>
+          </a:bodyPr>
+          <a:lstStyle/>
+          <a:p>
+            <a:pPr algn="ctr" a:rtl="1"/>
+            <a:r>
+              <a:rPr sz="1200" b="1">
                 <a:solidFill>
                   <a:srgbClr val="FFFFFF"/>
                 </a:solidFill>
                 <a:latin typeface="Tahoma"/>
               </a:rPr>
-              <a:t>۲</a:t>
-            </a:r>
-          </a:p>
-        </p:txBody>
-      </p:sp>
-      <p:sp>
-        <p:nvSpPr>
-          <p:cNvPr id="18" name="Rounded Rectangle 17"/>
+              <a:t>تعدیل پویا</a:t>
+            </a:r>
+          </a:p>
+        </p:txBody>
+      </p:sp>
+      <p:sp>
+        <p:nvSpPr>
+          <p:cNvPr id="20" name="TextBox 19"/>
+          <p:cNvSpPr txBox="1"/>
+          <p:nvPr/>
+        </p:nvSpPr>
+        <p:spPr>
+          <a:xfrm>
+            <a:off x="2295147" y="2670048"/>
+            <a:ext cx="1691639" cy="502920"/>
+          </a:xfrm>
+          <a:prstGeom prst="rect">
+            <a:avLst/>
+          </a:prstGeom>
+          <a:noFill/>
+        </p:spPr>
+        <p:txBody>
+          <a:bodyPr wrap="square" anchor="ctr">
+            <a:spAutoFit/>
+          </a:bodyPr>
+          <a:lstStyle/>
+          <a:p>
+            <a:pPr algn="ctr" a:rtl="1"/>
+            <a:r>
+              <a:rPr sz="850" b="0">
+                <a:solidFill>
+                  <a:srgbClr val="E0F2F1"/>
+                </a:solidFill>
+                <a:latin typeface="Tahoma"/>
+              </a:rPr>
+              <a:t>تبدیل وزن پایه به وزن تطبیقی با تابع نمایی</a:t>
+            </a:r>
+          </a:p>
+        </p:txBody>
+      </p:sp>
+      <p:sp>
+        <p:nvSpPr>
+          <p:cNvPr id="21" name="Rounded Rectangle 20"/>
           <p:cNvSpPr/>
           <p:nvPr/>
         </p:nvSpPr>
         <p:spPr>
           <a:xfrm>
-            <a:off x="4884420" y="3246120"/>
-            <a:ext cx="1874519" cy="868680"/>
+            <a:off x="-54860" y="1920240"/>
+            <a:ext cx="1874519" cy="1417320"/>
           </a:xfrm>
           <a:prstGeom prst="roundRect">
             <a:avLst>
-              <a:gd name="adj" fmla="val 10000"/>
+              <a:gd name="adj" fmla="val 8000"/>
             </a:avLst>
           </a:prstGeom>
           <a:solidFill>
-            <a:srgbClr val="FFFFFF"/>
+            <a:srgbClr val="1D4ED8"/>
           </a:solidFill>
-          <a:ln w="15240">
-            <a:solidFill>
-              <a:srgbClr val="D1D9E6"/>
-            </a:solidFill>
+          <a:ln>
+            <a:noFill/>
           </a:ln>
         </p:spPr>
         <p:style>
@@ -3811,90 +3925,20 @@
       </p:sp>
       <p:sp>
         <p:nvSpPr>
-          <p:cNvPr id="19" name="TextBox 18"/>
-          <p:cNvSpPr txBox="1"/>
-          <p:nvPr/>
-        </p:nvSpPr>
-        <p:spPr>
-          <a:xfrm>
-            <a:off x="4975860" y="3355848"/>
-            <a:ext cx="1691639" cy="292608"/>
-          </a:xfrm>
-          <a:prstGeom prst="rect">
-            <a:avLst/>
-          </a:prstGeom>
-          <a:noFill/>
-        </p:spPr>
-        <p:txBody>
-          <a:bodyPr wrap="square" anchor="ctr">
-            <a:spAutoFit/>
-          </a:bodyPr>
-          <a:lstStyle/>
-          <a:p>
-            <a:pPr algn="ctr" a:rtl="1"/>
-            <a:r>
-              <a:rPr sz="1100" b="1">
-                <a:solidFill>
-                  <a:srgbClr val="2D343E"/>
-                </a:solidFill>
-                <a:latin typeface="Tahoma"/>
-              </a:rPr>
-              <a:t>محاسبه وزن پایه (AHP)</a:t>
-            </a:r>
-          </a:p>
-        </p:txBody>
-      </p:sp>
-      <p:sp>
-        <p:nvSpPr>
-          <p:cNvPr id="20" name="TextBox 19"/>
-          <p:cNvSpPr txBox="1"/>
-          <p:nvPr/>
-        </p:nvSpPr>
-        <p:spPr>
-          <a:xfrm>
-            <a:off x="4975860" y="3648456"/>
-            <a:ext cx="1691639" cy="457200"/>
-          </a:xfrm>
-          <a:prstGeom prst="rect">
-            <a:avLst/>
-          </a:prstGeom>
-          <a:noFill/>
-        </p:spPr>
-        <p:txBody>
-          <a:bodyPr wrap="square" anchor="ctr">
-            <a:spAutoFit/>
-          </a:bodyPr>
-          <a:lstStyle/>
-          <a:p>
-            <a:pPr algn="ctr" a:rtl="1"/>
-            <a:r>
-              <a:rPr sz="900" b="0">
-                <a:solidFill>
-                  <a:srgbClr val="6B7280"/>
-                </a:solidFill>
-                <a:latin typeface="Tahoma"/>
-              </a:rPr>
-              <a:t>بردار وزن معیارها از قضاوت خبرگان</a:t>
-            </a:r>
-          </a:p>
-        </p:txBody>
-      </p:sp>
-      <p:sp>
-        <p:nvSpPr>
-          <p:cNvPr id="21" name="Rectangle 20"/>
+          <p:cNvPr id="22" name="Oval 21"/>
           <p:cNvSpPr/>
           <p:nvPr/>
         </p:nvSpPr>
         <p:spPr>
           <a:xfrm>
-            <a:off x="5806440" y="3099816"/>
-            <a:ext cx="30480" cy="146304"/>
-          </a:xfrm>
-          <a:prstGeom prst="rect">
+            <a:off x="644655" y="1975104"/>
+            <a:ext cx="475488" cy="475488"/>
+          </a:xfrm>
+          <a:prstGeom prst="ellipse">
             <a:avLst/>
           </a:prstGeom>
           <a:solidFill>
-            <a:srgbClr val="2B5C8A"/>
+            <a:srgbClr val="FFFFFF"/>
           </a:solidFill>
           <a:ln>
             <a:noFill/>
@@ -3919,30 +3963,107 @@
           <a:lstStyle/>
           <a:p>
             <a:pPr algn="ctr"/>
-          </a:p>
-        </p:txBody>
-      </p:sp>
-      <p:sp>
-        <p:nvSpPr>
-          <p:cNvPr id="22" name="Oval 21"/>
+            <a:r>
+              <a:rPr sz="1200" b="1">
+                <a:solidFill>
+                  <a:srgbClr val="1D4ED8"/>
+                </a:solidFill>
+                <a:latin typeface="Tahoma"/>
+              </a:rPr>
+              <a:t>۴</a:t>
+            </a:r>
+          </a:p>
+        </p:txBody>
+      </p:sp>
+      <p:sp>
+        <p:nvSpPr>
+          <p:cNvPr id="23" name="TextBox 22"/>
+          <p:cNvSpPr txBox="1"/>
+          <p:nvPr/>
+        </p:nvSpPr>
+        <p:spPr>
+          <a:xfrm>
+            <a:off x="36580" y="2395728"/>
+            <a:ext cx="1691639" cy="274320"/>
+          </a:xfrm>
+          <a:prstGeom prst="rect">
+            <a:avLst/>
+          </a:prstGeom>
+          <a:noFill/>
+        </p:spPr>
+        <p:txBody>
+          <a:bodyPr wrap="square" anchor="ctr">
+            <a:spAutoFit/>
+          </a:bodyPr>
+          <a:lstStyle/>
+          <a:p>
+            <a:pPr algn="ctr" a:rtl="1"/>
+            <a:r>
+              <a:rPr sz="1200" b="1">
+                <a:solidFill>
+                  <a:srgbClr val="FFFFFF"/>
+                </a:solidFill>
+                <a:latin typeface="Tahoma"/>
+              </a:rPr>
+              <a:t>رتبه‌بندی TOPSIS</a:t>
+            </a:r>
+          </a:p>
+        </p:txBody>
+      </p:sp>
+      <p:sp>
+        <p:nvSpPr>
+          <p:cNvPr id="24" name="TextBox 23"/>
+          <p:cNvSpPr txBox="1"/>
+          <p:nvPr/>
+        </p:nvSpPr>
+        <p:spPr>
+          <a:xfrm>
+            <a:off x="36580" y="2670048"/>
+            <a:ext cx="1691639" cy="502920"/>
+          </a:xfrm>
+          <a:prstGeom prst="rect">
+            <a:avLst/>
+          </a:prstGeom>
+          <a:noFill/>
+        </p:spPr>
+        <p:txBody>
+          <a:bodyPr wrap="square" anchor="ctr">
+            <a:spAutoFit/>
+          </a:bodyPr>
+          <a:lstStyle/>
+          <a:p>
+            <a:pPr algn="ctr" a:rtl="1"/>
+            <a:r>
+              <a:rPr sz="850" b="0">
+                <a:solidFill>
+                  <a:srgbClr val="DBEAFE"/>
+                </a:solidFill>
+                <a:latin typeface="Tahoma"/>
+              </a:rPr>
+              <a:t>انتخاب فناوری برتر در خوشه منتخب</a:t>
+            </a:r>
+          </a:p>
+        </p:txBody>
+      </p:sp>
+      <p:sp>
+        <p:nvSpPr>
+          <p:cNvPr id="25" name="Rectangle 24"/>
           <p:cNvSpPr/>
           <p:nvPr/>
         </p:nvSpPr>
         <p:spPr>
           <a:xfrm>
-            <a:off x="3002280" y="2468880"/>
-            <a:ext cx="640080" cy="640080"/>
-          </a:xfrm>
-          <a:prstGeom prst="ellipse">
+            <a:off x="-54860" y="3657600"/>
+            <a:ext cx="8650220" cy="38100"/>
+          </a:xfrm>
+          <a:prstGeom prst="rect">
             <a:avLst/>
           </a:prstGeom>
           <a:solidFill>
-            <a:srgbClr val="FFFFFF"/>
+            <a:srgbClr val="CBD5E1"/>
           </a:solidFill>
-          <a:ln w="38100">
-            <a:solidFill>
-              <a:srgbClr val="009688"/>
-            </a:solidFill>
+          <a:ln>
+            <a:noFill/>
           </a:ln>
         </p:spPr>
         <p:style>
@@ -3969,113 +4090,14 @@
       </p:sp>
       <p:sp>
         <p:nvSpPr>
-          <p:cNvPr id="23" name="Oval 22"/>
-          <p:cNvSpPr/>
-          <p:nvPr/>
-        </p:nvSpPr>
-        <p:spPr>
-          <a:xfrm>
-            <a:off x="3048000" y="2514600"/>
-            <a:ext cx="548640" cy="548640"/>
-          </a:xfrm>
-          <a:prstGeom prst="ellipse">
-            <a:avLst/>
-          </a:prstGeom>
-          <a:solidFill>
-            <a:srgbClr val="009688"/>
-          </a:solidFill>
-          <a:ln>
-            <a:noFill/>
-          </a:ln>
-        </p:spPr>
-        <p:style>
-          <a:lnRef idx="1">
-            <a:schemeClr val="accent1"/>
-          </a:lnRef>
-          <a:fillRef idx="3">
-            <a:schemeClr val="accent1"/>
-          </a:fillRef>
-          <a:effectRef idx="2">
-            <a:schemeClr val="accent1"/>
-          </a:effectRef>
-          <a:fontRef idx="minor">
-            <a:schemeClr val="lt1"/>
-          </a:fontRef>
-        </p:style>
-        <p:txBody>
-          <a:bodyPr rtlCol="0" anchor="ctr"/>
-          <a:lstStyle/>
-          <a:p>
-            <a:pPr algn="ctr"/>
-            <a:r>
-              <a:rPr sz="1500" b="1">
-                <a:solidFill>
-                  <a:srgbClr val="FFFFFF"/>
-                </a:solidFill>
-                <a:latin typeface="Tahoma"/>
-              </a:rPr>
-              <a:t>۳</a:t>
-            </a:r>
-          </a:p>
-        </p:txBody>
-      </p:sp>
-      <p:sp>
-        <p:nvSpPr>
-          <p:cNvPr id="24" name="Rounded Rectangle 23"/>
-          <p:cNvSpPr/>
-          <p:nvPr/>
-        </p:nvSpPr>
-        <p:spPr>
-          <a:xfrm>
-            <a:off x="2385060" y="1463040"/>
-            <a:ext cx="1874519" cy="868680"/>
-          </a:xfrm>
-          <a:prstGeom prst="roundRect">
-            <a:avLst>
-              <a:gd name="adj" fmla="val 10000"/>
-            </a:avLst>
-          </a:prstGeom>
-          <a:solidFill>
-            <a:srgbClr val="FFFFFF"/>
-          </a:solidFill>
-          <a:ln w="25400">
-            <a:solidFill>
-              <a:srgbClr val="009688"/>
-            </a:solidFill>
-          </a:ln>
-        </p:spPr>
-        <p:style>
-          <a:lnRef idx="1">
-            <a:schemeClr val="accent1"/>
-          </a:lnRef>
-          <a:fillRef idx="3">
-            <a:schemeClr val="accent1"/>
-          </a:fillRef>
-          <a:effectRef idx="2">
-            <a:schemeClr val="accent1"/>
-          </a:effectRef>
-          <a:fontRef idx="minor">
-            <a:schemeClr val="lt1"/>
-          </a:fontRef>
-        </p:style>
-        <p:txBody>
-          <a:bodyPr rtlCol="0" anchor="ctr"/>
-          <a:lstStyle/>
-          <a:p>
-            <a:pPr algn="ctr"/>
-          </a:p>
-        </p:txBody>
-      </p:sp>
-      <p:sp>
-        <p:nvSpPr>
-          <p:cNvPr id="25" name="TextBox 24"/>
+          <p:cNvPr id="26" name="TextBox 25"/>
           <p:cNvSpPr txBox="1"/>
           <p:nvPr/>
         </p:nvSpPr>
         <p:spPr>
           <a:xfrm>
-            <a:off x="2476500" y="1572768"/>
-            <a:ext cx="1691639" cy="292608"/>
+            <a:off x="6720841" y="3749040"/>
+            <a:ext cx="1874519" cy="228600"/>
           </a:xfrm>
           <a:prstGeom prst="rect">
             <a:avLst/>
@@ -4090,27 +4112,27 @@
           <a:p>
             <a:pPr algn="ctr" a:rtl="1"/>
             <a:r>
-              <a:rPr sz="1100" b="1">
+              <a:rPr sz="800" b="0">
                 <a:solidFill>
-                  <a:srgbClr val="2D343E"/>
+                  <a:srgbClr val="64748B"/>
                 </a:solidFill>
                 <a:latin typeface="Tahoma"/>
               </a:rPr>
-              <a:t>تعدیل پویای وزن</a:t>
-            </a:r>
-          </a:p>
-        </p:txBody>
-      </p:sp>
-      <p:sp>
-        <p:nvSpPr>
-          <p:cNvPr id="26" name="TextBox 25"/>
+              <a:t>گردآوری</a:t>
+            </a:r>
+          </a:p>
+        </p:txBody>
+      </p:sp>
+      <p:sp>
+        <p:nvSpPr>
+          <p:cNvPr id="27" name="TextBox 26"/>
           <p:cNvSpPr txBox="1"/>
           <p:nvPr/>
         </p:nvSpPr>
         <p:spPr>
           <a:xfrm>
-            <a:off x="2476500" y="1865376"/>
-            <a:ext cx="1691639" cy="457200"/>
+            <a:off x="4462274" y="3749040"/>
+            <a:ext cx="1874519" cy="228600"/>
           </a:xfrm>
           <a:prstGeom prst="rect">
             <a:avLst/>
@@ -4125,126 +4147,27 @@
           <a:p>
             <a:pPr algn="ctr" a:rtl="1"/>
             <a:r>
-              <a:rPr sz="900" b="0">
+              <a:rPr sz="800" b="0">
                 <a:solidFill>
-                  <a:srgbClr val="6B7280"/>
+                  <a:srgbClr val="64748B"/>
                 </a:solidFill>
                 <a:latin typeface="Tahoma"/>
               </a:rPr>
-              <a:t>تبدیل وزن پایه به وزن تطبیقی — نوآوری</a:t>
-            </a:r>
-          </a:p>
-        </p:txBody>
-      </p:sp>
-      <p:sp>
-        <p:nvSpPr>
-          <p:cNvPr id="27" name="Rounded Rectangle 26"/>
-          <p:cNvSpPr/>
-          <p:nvPr/>
-        </p:nvSpPr>
-        <p:spPr>
-          <a:xfrm>
-            <a:off x="2522220" y="2057400"/>
-            <a:ext cx="1600199" cy="201168"/>
-          </a:xfrm>
-          <a:prstGeom prst="roundRect">
-            <a:avLst>
-              <a:gd name="adj" fmla="val 10000"/>
-            </a:avLst>
-          </a:prstGeom>
-          <a:solidFill>
-            <a:srgbClr val="E8F5E9"/>
-          </a:solidFill>
-          <a:ln w="12700">
-            <a:solidFill>
-              <a:srgbClr val="2E7D32"/>
-            </a:solidFill>
-          </a:ln>
-        </p:spPr>
-        <p:style>
-          <a:lnRef idx="1">
-            <a:schemeClr val="accent1"/>
-          </a:lnRef>
-          <a:fillRef idx="3">
-            <a:schemeClr val="accent1"/>
-          </a:fillRef>
-          <a:effectRef idx="2">
-            <a:schemeClr val="accent1"/>
-          </a:effectRef>
-          <a:fontRef idx="minor">
-            <a:schemeClr val="lt1"/>
-          </a:fontRef>
-        </p:style>
-        <p:txBody>
-          <a:bodyPr rtlCol="0" anchor="ctr"/>
-          <a:lstStyle/>
-          <a:p>
-            <a:pPr algn="ctr" a:rtl="1"/>
-            <a:r>
-              <a:rPr sz="800" b="1">
-                <a:solidFill>
-                  <a:srgbClr val="2E7D32"/>
-                </a:solidFill>
-                <a:latin typeface="Tahoma"/>
-              </a:rPr>
-              <a:t>تعدیل نمایی</a:t>
-            </a:r>
-          </a:p>
-        </p:txBody>
-      </p:sp>
-      <p:sp>
-        <p:nvSpPr>
-          <p:cNvPr id="28" name="Rectangle 27"/>
-          <p:cNvSpPr/>
-          <p:nvPr/>
-        </p:nvSpPr>
-        <p:spPr>
-          <a:xfrm>
-            <a:off x="3307080" y="2331720"/>
-            <a:ext cx="30480" cy="146304"/>
-          </a:xfrm>
-          <a:prstGeom prst="rect">
-            <a:avLst/>
-          </a:prstGeom>
-          <a:solidFill>
-            <a:srgbClr val="009688"/>
-          </a:solidFill>
-          <a:ln>
-            <a:noFill/>
-          </a:ln>
-        </p:spPr>
-        <p:style>
-          <a:lnRef idx="1">
-            <a:schemeClr val="accent1"/>
-          </a:lnRef>
-          <a:fillRef idx="3">
-            <a:schemeClr val="accent1"/>
-          </a:fillRef>
-          <a:effectRef idx="2">
-            <a:schemeClr val="accent1"/>
-          </a:effectRef>
-          <a:fontRef idx="minor">
-            <a:schemeClr val="lt1"/>
-          </a:fontRef>
-        </p:style>
-        <p:txBody>
-          <a:bodyPr rtlCol="0" anchor="ctr"/>
-          <a:lstStyle/>
-          <a:p>
-            <a:pPr algn="ctr"/>
-          </a:p>
-        </p:txBody>
-      </p:sp>
-      <p:sp>
-        <p:nvSpPr>
-          <p:cNvPr id="29" name="TextBox 28"/>
+              <a:t>تحلیل</a:t>
+            </a:r>
+          </a:p>
+        </p:txBody>
+      </p:sp>
+      <p:sp>
+        <p:nvSpPr>
+          <p:cNvPr id="28" name="TextBox 27"/>
           <p:cNvSpPr txBox="1"/>
           <p:nvPr/>
         </p:nvSpPr>
         <p:spPr>
           <a:xfrm>
-            <a:off x="2910840" y="2167128"/>
-            <a:ext cx="822960" cy="201168"/>
+            <a:off x="2203707" y="3749040"/>
+            <a:ext cx="1874519" cy="228600"/>
           </a:xfrm>
           <a:prstGeom prst="rect">
             <a:avLst/>
@@ -4259,9 +4182,9 @@
           <a:p>
             <a:pPr algn="ctr" a:rtl="1"/>
             <a:r>
-              <a:rPr sz="800" b="1">
+              <a:rPr sz="800" b="0">
                 <a:solidFill>
-                  <a:srgbClr val="009688"/>
+                  <a:srgbClr val="64748B"/>
                 </a:solidFill>
                 <a:latin typeface="Tahoma"/>
               </a:rPr>
@@ -4272,158 +4195,14 @@
       </p:sp>
       <p:sp>
         <p:nvSpPr>
-          <p:cNvPr id="30" name="Oval 29"/>
-          <p:cNvSpPr/>
-          <p:nvPr/>
-        </p:nvSpPr>
-        <p:spPr>
-          <a:xfrm>
-            <a:off x="502920" y="2468880"/>
-            <a:ext cx="640080" cy="640080"/>
-          </a:xfrm>
-          <a:prstGeom prst="ellipse">
-            <a:avLst/>
-          </a:prstGeom>
-          <a:solidFill>
-            <a:srgbClr val="FFFFFF"/>
-          </a:solidFill>
-          <a:ln w="38100">
-            <a:solidFill>
-              <a:srgbClr val="1E3A5F"/>
-            </a:solidFill>
-          </a:ln>
-        </p:spPr>
-        <p:style>
-          <a:lnRef idx="1">
-            <a:schemeClr val="accent1"/>
-          </a:lnRef>
-          <a:fillRef idx="3">
-            <a:schemeClr val="accent1"/>
-          </a:fillRef>
-          <a:effectRef idx="2">
-            <a:schemeClr val="accent1"/>
-          </a:effectRef>
-          <a:fontRef idx="minor">
-            <a:schemeClr val="lt1"/>
-          </a:fontRef>
-        </p:style>
-        <p:txBody>
-          <a:bodyPr rtlCol="0" anchor="ctr"/>
-          <a:lstStyle/>
-          <a:p>
-            <a:pPr algn="ctr"/>
-          </a:p>
-        </p:txBody>
-      </p:sp>
-      <p:sp>
-        <p:nvSpPr>
-          <p:cNvPr id="31" name="Oval 30"/>
-          <p:cNvSpPr/>
-          <p:nvPr/>
-        </p:nvSpPr>
-        <p:spPr>
-          <a:xfrm>
-            <a:off x="548640" y="2514600"/>
-            <a:ext cx="548640" cy="548640"/>
-          </a:xfrm>
-          <a:prstGeom prst="ellipse">
-            <a:avLst/>
-          </a:prstGeom>
-          <a:solidFill>
-            <a:srgbClr val="1E3A5F"/>
-          </a:solidFill>
-          <a:ln>
-            <a:noFill/>
-          </a:ln>
-        </p:spPr>
-        <p:style>
-          <a:lnRef idx="1">
-            <a:schemeClr val="accent1"/>
-          </a:lnRef>
-          <a:fillRef idx="3">
-            <a:schemeClr val="accent1"/>
-          </a:fillRef>
-          <a:effectRef idx="2">
-            <a:schemeClr val="accent1"/>
-          </a:effectRef>
-          <a:fontRef idx="minor">
-            <a:schemeClr val="lt1"/>
-          </a:fontRef>
-        </p:style>
-        <p:txBody>
-          <a:bodyPr rtlCol="0" anchor="ctr"/>
-          <a:lstStyle/>
-          <a:p>
-            <a:pPr algn="ctr"/>
-            <a:r>
-              <a:rPr sz="1500" b="1">
-                <a:solidFill>
-                  <a:srgbClr val="FFFFFF"/>
-                </a:solidFill>
-                <a:latin typeface="Tahoma"/>
-              </a:rPr>
-              <a:t>۴</a:t>
-            </a:r>
-          </a:p>
-        </p:txBody>
-      </p:sp>
-      <p:sp>
-        <p:nvSpPr>
-          <p:cNvPr id="32" name="Rounded Rectangle 31"/>
-          <p:cNvSpPr/>
-          <p:nvPr/>
-        </p:nvSpPr>
-        <p:spPr>
-          <a:xfrm>
-            <a:off x="-114299" y="3246120"/>
-            <a:ext cx="1874519" cy="868680"/>
-          </a:xfrm>
-          <a:prstGeom prst="roundRect">
-            <a:avLst>
-              <a:gd name="adj" fmla="val 10000"/>
-            </a:avLst>
-          </a:prstGeom>
-          <a:solidFill>
-            <a:srgbClr val="1E3A5F"/>
-          </a:solidFill>
-          <a:ln w="25400">
-            <a:solidFill>
-              <a:srgbClr val="1E3A5F"/>
-            </a:solidFill>
-          </a:ln>
-        </p:spPr>
-        <p:style>
-          <a:lnRef idx="1">
-            <a:schemeClr val="accent1"/>
-          </a:lnRef>
-          <a:fillRef idx="3">
-            <a:schemeClr val="accent1"/>
-          </a:fillRef>
-          <a:effectRef idx="2">
-            <a:schemeClr val="accent1"/>
-          </a:effectRef>
-          <a:fontRef idx="minor">
-            <a:schemeClr val="lt1"/>
-          </a:fontRef>
-        </p:style>
-        <p:txBody>
-          <a:bodyPr rtlCol="0" anchor="ctr"/>
-          <a:lstStyle/>
-          <a:p>
-            <a:pPr algn="ctr"/>
-          </a:p>
-        </p:txBody>
-      </p:sp>
-      <p:sp>
-        <p:nvSpPr>
-          <p:cNvPr id="33" name="TextBox 32"/>
+          <p:cNvPr id="29" name="TextBox 28"/>
           <p:cNvSpPr txBox="1"/>
           <p:nvPr/>
         </p:nvSpPr>
         <p:spPr>
           <a:xfrm>
-            <a:off x="-22859" y="3355848"/>
-            <a:ext cx="1691639" cy="292608"/>
+            <a:off x="-54860" y="3749040"/>
+            <a:ext cx="1874519" cy="228600"/>
           </a:xfrm>
           <a:prstGeom prst="rect">
             <a:avLst/>
@@ -4438,442 +4217,13 @@
           <a:p>
             <a:pPr algn="ctr" a:rtl="1"/>
             <a:r>
-              <a:rPr sz="1100" b="1">
+              <a:rPr sz="800" b="0">
                 <a:solidFill>
-                  <a:srgbClr val="FFFFFF"/>
+                  <a:srgbClr val="64748B"/>
                 </a:solidFill>
                 <a:latin typeface="Tahoma"/>
               </a:rPr>
-              <a:t>رتبه‌بندی (TOPSIS)</a:t>
-            </a:r>
-          </a:p>
-        </p:txBody>
-      </p:sp>
-      <p:sp>
-        <p:nvSpPr>
-          <p:cNvPr id="34" name="TextBox 33"/>
-          <p:cNvSpPr txBox="1"/>
-          <p:nvPr/>
-        </p:nvSpPr>
-        <p:spPr>
-          <a:xfrm>
-            <a:off x="-22859" y="3648456"/>
-            <a:ext cx="1691639" cy="457200"/>
-          </a:xfrm>
-          <a:prstGeom prst="rect">
-            <a:avLst/>
-          </a:prstGeom>
-          <a:noFill/>
-        </p:spPr>
-        <p:txBody>
-          <a:bodyPr wrap="square" anchor="ctr">
-            <a:spAutoFit/>
-          </a:bodyPr>
-          <a:lstStyle/>
-          <a:p>
-            <a:pPr algn="ctr" a:rtl="1"/>
-            <a:r>
-              <a:rPr sz="900" b="0">
-                <a:solidFill>
-                  <a:srgbClr val="BBDEFB"/>
-                </a:solidFill>
-                <a:latin typeface="Tahoma"/>
-              </a:rPr>
-              <a:t>انتخاب فناوری برتر در خوشه منتخب</a:t>
-            </a:r>
-          </a:p>
-        </p:txBody>
-      </p:sp>
-      <p:sp>
-        <p:nvSpPr>
-          <p:cNvPr id="35" name="Rectangle 34"/>
-          <p:cNvSpPr/>
-          <p:nvPr/>
-        </p:nvSpPr>
-        <p:spPr>
-          <a:xfrm>
-            <a:off x="807720" y="3099816"/>
-            <a:ext cx="30480" cy="146304"/>
-          </a:xfrm>
-          <a:prstGeom prst="rect">
-            <a:avLst/>
-          </a:prstGeom>
-          <a:solidFill>
-            <a:srgbClr val="1E3A5F"/>
-          </a:solidFill>
-          <a:ln>
-            <a:noFill/>
-          </a:ln>
-        </p:spPr>
-        <p:style>
-          <a:lnRef idx="1">
-            <a:schemeClr val="accent1"/>
-          </a:lnRef>
-          <a:fillRef idx="3">
-            <a:schemeClr val="accent1"/>
-          </a:fillRef>
-          <a:effectRef idx="2">
-            <a:schemeClr val="accent1"/>
-          </a:effectRef>
-          <a:fontRef idx="minor">
-            <a:schemeClr val="lt1"/>
-          </a:fontRef>
-        </p:style>
-        <p:txBody>
-          <a:bodyPr rtlCol="0" anchor="ctr"/>
-          <a:lstStyle/>
-          <a:p>
-            <a:pPr algn="ctr"/>
-          </a:p>
-        </p:txBody>
-      </p:sp>
-      <p:sp>
-        <p:nvSpPr>
-          <p:cNvPr id="36" name="TextBox 35"/>
-          <p:cNvSpPr txBox="1"/>
-          <p:nvPr/>
-        </p:nvSpPr>
-        <p:spPr>
-          <a:xfrm>
-            <a:off x="411480" y="3172968"/>
-            <a:ext cx="822960" cy="201168"/>
-          </a:xfrm>
-          <a:prstGeom prst="rect">
-            <a:avLst/>
-          </a:prstGeom>
-          <a:noFill/>
-        </p:spPr>
-        <p:txBody>
-          <a:bodyPr wrap="square" anchor="ctr">
-            <a:spAutoFit/>
-          </a:bodyPr>
-          <a:lstStyle/>
-          <a:p>
-            <a:pPr algn="ctr" a:rtl="1"/>
-            <a:r>
-              <a:rPr sz="800" b="1">
-                <a:solidFill>
-                  <a:srgbClr val="1E3A5F"/>
-                </a:solidFill>
-                <a:latin typeface="Tahoma"/>
-              </a:rPr>
-              <a:t>پایان</a:t>
-            </a:r>
-          </a:p>
-        </p:txBody>
-      </p:sp>
-      <p:sp>
-        <p:nvSpPr>
-          <p:cNvPr id="37" name="Rounded Rectangle 36"/>
-          <p:cNvSpPr/>
-          <p:nvPr/>
-        </p:nvSpPr>
-        <p:spPr>
-          <a:xfrm>
-            <a:off x="411480" y="4160520"/>
-            <a:ext cx="8321040" cy="658368"/>
-          </a:xfrm>
-          <a:prstGeom prst="roundRect">
-            <a:avLst>
-              <a:gd name="adj" fmla="val 10000"/>
-            </a:avLst>
-          </a:prstGeom>
-          <a:solidFill>
-            <a:srgbClr val="FFFFFF"/>
-          </a:solidFill>
-          <a:ln w="19050">
-            <a:solidFill>
-              <a:srgbClr val="D1D9E6"/>
-            </a:solidFill>
-          </a:ln>
-        </p:spPr>
-        <p:style>
-          <a:lnRef idx="1">
-            <a:schemeClr val="accent1"/>
-          </a:lnRef>
-          <a:fillRef idx="3">
-            <a:schemeClr val="accent1"/>
-          </a:fillRef>
-          <a:effectRef idx="2">
-            <a:schemeClr val="accent1"/>
-          </a:effectRef>
-          <a:fontRef idx="minor">
-            <a:schemeClr val="lt1"/>
-          </a:fontRef>
-        </p:style>
-        <p:txBody>
-          <a:bodyPr rtlCol="0" anchor="ctr"/>
-          <a:lstStyle/>
-          <a:p>
-            <a:pPr algn="ctr"/>
-          </a:p>
-        </p:txBody>
-      </p:sp>
-      <p:sp>
-        <p:nvSpPr>
-          <p:cNvPr id="38" name="Oval 37"/>
-          <p:cNvSpPr/>
-          <p:nvPr/>
-        </p:nvSpPr>
-        <p:spPr>
-          <a:xfrm>
-            <a:off x="1097280" y="4370832"/>
-            <a:ext cx="128016" cy="128016"/>
-          </a:xfrm>
-          <a:prstGeom prst="ellipse">
-            <a:avLst/>
-          </a:prstGeom>
-          <a:solidFill>
-            <a:srgbClr val="2B5C8A"/>
-          </a:solidFill>
-          <a:ln>
-            <a:noFill/>
-          </a:ln>
-        </p:spPr>
-        <p:style>
-          <a:lnRef idx="1">
-            <a:schemeClr val="accent1"/>
-          </a:lnRef>
-          <a:fillRef idx="3">
-            <a:schemeClr val="accent1"/>
-          </a:fillRef>
-          <a:effectRef idx="2">
-            <a:schemeClr val="accent1"/>
-          </a:effectRef>
-          <a:fontRef idx="minor">
-            <a:schemeClr val="lt1"/>
-          </a:fontRef>
-        </p:style>
-        <p:txBody>
-          <a:bodyPr rtlCol="0" anchor="ctr"/>
-          <a:lstStyle/>
-          <a:p>
-            <a:pPr algn="ctr"/>
-          </a:p>
-        </p:txBody>
-      </p:sp>
-      <p:sp>
-        <p:nvSpPr>
-          <p:cNvPr id="39" name="TextBox 38"/>
-          <p:cNvSpPr txBox="1"/>
-          <p:nvPr/>
-        </p:nvSpPr>
-        <p:spPr>
-          <a:xfrm>
-            <a:off x="1280160" y="4315968"/>
-            <a:ext cx="2011680" cy="256032"/>
-          </a:xfrm>
-          <a:prstGeom prst="rect">
-            <a:avLst/>
-          </a:prstGeom>
-          <a:noFill/>
-        </p:spPr>
-        <p:txBody>
-          <a:bodyPr wrap="square" anchor="ctr">
-            <a:spAutoFit/>
-          </a:bodyPr>
-          <a:lstStyle/>
-          <a:p>
-            <a:pPr algn="ctr" a:rtl="1"/>
-            <a:r>
-              <a:rPr sz="900" b="0">
-                <a:solidFill>
-                  <a:srgbClr val="2D343E"/>
-                </a:solidFill>
-                <a:latin typeface="Tahoma"/>
-              </a:rPr>
-              <a:t>فاز پردازش</a:t>
-            </a:r>
-          </a:p>
-        </p:txBody>
-      </p:sp>
-      <p:sp>
-        <p:nvSpPr>
-          <p:cNvPr id="40" name="Oval 39"/>
-          <p:cNvSpPr/>
-          <p:nvPr/>
-        </p:nvSpPr>
-        <p:spPr>
-          <a:xfrm>
-            <a:off x="3657600" y="4370832"/>
-            <a:ext cx="128016" cy="128016"/>
-          </a:xfrm>
-          <a:prstGeom prst="ellipse">
-            <a:avLst/>
-          </a:prstGeom>
-          <a:solidFill>
-            <a:srgbClr val="009688"/>
-          </a:solidFill>
-          <a:ln>
-            <a:noFill/>
-          </a:ln>
-        </p:spPr>
-        <p:style>
-          <a:lnRef idx="1">
-            <a:schemeClr val="accent1"/>
-          </a:lnRef>
-          <a:fillRef idx="3">
-            <a:schemeClr val="accent1"/>
-          </a:fillRef>
-          <a:effectRef idx="2">
-            <a:schemeClr val="accent1"/>
-          </a:effectRef>
-          <a:fontRef idx="minor">
-            <a:schemeClr val="lt1"/>
-          </a:fontRef>
-        </p:style>
-        <p:txBody>
-          <a:bodyPr rtlCol="0" anchor="ctr"/>
-          <a:lstStyle/>
-          <a:p>
-            <a:pPr algn="ctr"/>
-          </a:p>
-        </p:txBody>
-      </p:sp>
-      <p:sp>
-        <p:nvSpPr>
-          <p:cNvPr id="41" name="TextBox 40"/>
-          <p:cNvSpPr txBox="1"/>
-          <p:nvPr/>
-        </p:nvSpPr>
-        <p:spPr>
-          <a:xfrm>
-            <a:off x="3840480" y="4315968"/>
-            <a:ext cx="2011680" cy="256032"/>
-          </a:xfrm>
-          <a:prstGeom prst="rect">
-            <a:avLst/>
-          </a:prstGeom>
-          <a:noFill/>
-        </p:spPr>
-        <p:txBody>
-          <a:bodyPr wrap="square" anchor="ctr">
-            <a:spAutoFit/>
-          </a:bodyPr>
-          <a:lstStyle/>
-          <a:p>
-            <a:pPr algn="ctr" a:rtl="1"/>
-            <a:r>
-              <a:rPr sz="900" b="0">
-                <a:solidFill>
-                  <a:srgbClr val="2D343E"/>
-                </a:solidFill>
-                <a:latin typeface="Tahoma"/>
-              </a:rPr>
-              <a:t>فاز نوآورانه (تعدیل پویا)</a:t>
-            </a:r>
-          </a:p>
-        </p:txBody>
-      </p:sp>
-      <p:sp>
-        <p:nvSpPr>
-          <p:cNvPr id="42" name="Oval 41"/>
-          <p:cNvSpPr/>
-          <p:nvPr/>
-        </p:nvSpPr>
-        <p:spPr>
-          <a:xfrm>
-            <a:off x="6217920" y="4370832"/>
-            <a:ext cx="128016" cy="128016"/>
-          </a:xfrm>
-          <a:prstGeom prst="ellipse">
-            <a:avLst/>
-          </a:prstGeom>
-          <a:solidFill>
-            <a:srgbClr val="1E3A5F"/>
-          </a:solidFill>
-          <a:ln>
-            <a:noFill/>
-          </a:ln>
-        </p:spPr>
-        <p:style>
-          <a:lnRef idx="1">
-            <a:schemeClr val="accent1"/>
-          </a:lnRef>
-          <a:fillRef idx="3">
-            <a:schemeClr val="accent1"/>
-          </a:fillRef>
-          <a:effectRef idx="2">
-            <a:schemeClr val="accent1"/>
-          </a:effectRef>
-          <a:fontRef idx="minor">
-            <a:schemeClr val="lt1"/>
-          </a:fontRef>
-        </p:style>
-        <p:txBody>
-          <a:bodyPr rtlCol="0" anchor="ctr"/>
-          <a:lstStyle/>
-          <a:p>
-            <a:pPr algn="ctr"/>
-          </a:p>
-        </p:txBody>
-      </p:sp>
-      <p:sp>
-        <p:nvSpPr>
-          <p:cNvPr id="43" name="TextBox 42"/>
-          <p:cNvSpPr txBox="1"/>
-          <p:nvPr/>
-        </p:nvSpPr>
-        <p:spPr>
-          <a:xfrm>
-            <a:off x="6400800" y="4315968"/>
-            <a:ext cx="2011680" cy="256032"/>
-          </a:xfrm>
-          <a:prstGeom prst="rect">
-            <a:avLst/>
-          </a:prstGeom>
-          <a:noFill/>
-        </p:spPr>
-        <p:txBody>
-          <a:bodyPr wrap="square" anchor="ctr">
-            <a:spAutoFit/>
-          </a:bodyPr>
-          <a:lstStyle/>
-          <a:p>
-            <a:pPr algn="ctr" a:rtl="1"/>
-            <a:r>
-              <a:rPr sz="900" b="0">
-                <a:solidFill>
-                  <a:srgbClr val="2D343E"/>
-                </a:solidFill>
-                <a:latin typeface="Tahoma"/>
-              </a:rPr>
-              <a:t>خروجی نهایی</a:t>
-            </a:r>
-          </a:p>
-        </p:txBody>
-      </p:sp>
-      <p:sp>
-        <p:nvSpPr>
-          <p:cNvPr id="44" name="TextBox 43"/>
-          <p:cNvSpPr txBox="1"/>
-          <p:nvPr/>
-        </p:nvSpPr>
-        <p:spPr>
-          <a:xfrm>
-            <a:off x="411480" y="4681728"/>
-            <a:ext cx="8321040" cy="201168"/>
-          </a:xfrm>
-          <a:prstGeom prst="rect">
-            <a:avLst/>
-          </a:prstGeom>
-          <a:noFill/>
-        </p:spPr>
-        <p:txBody>
-          <a:bodyPr wrap="square" anchor="ctr">
-            <a:spAutoFit/>
-          </a:bodyPr>
-          <a:lstStyle/>
-          <a:p>
-            <a:pPr algn="l" a:rtl="1"/>
-            <a:r>
-              <a:rPr sz="900" b="0">
-                <a:solidFill>
-                  <a:srgbClr val="6B7280"/>
-                </a:solidFill>
-                <a:latin typeface="Tahoma"/>
-              </a:rPr>
-              <a:t>روش پیشنهادی  |  AHP + تعدیل پویا + TOPSIS</a:t>
+              <a:t>خروجی</a:t>
             </a:r>
           </a:p>
         </p:txBody>

</xml_diff>